<commit_message>
docs: add real AWS EKS deployment evidence and update deck and walkthrough
terraform apply provisioned the VPC and EKS 1.35 in ap-south-1; MediSlot was
deployed with Helm and verified through ingress-nginx. Adds CLI evidence of the
cluster, node group, VPC and subnets, the app and Helm release on EKS, and two
new slides with narration to the presentation and video.
</commit_message>
<xml_diff>
--- a/docs/presentation/MediSlot-presentation.pptx
+++ b/docs/presentation/MediSlot-presentation.pptx
@@ -22,6 +22,8 @@
     <p:sldId id="270" r:id="rId22"/>
     <p:sldId id="271" r:id="rId23"/>
     <p:sldId id="272" r:id="rId24"/>
+    <p:sldId id="273" r:id="rId25"/>
+    <p:sldId id="274" r:id="rId26"/>
   </p:sldIdLst>
   <p:sldSz cx="12192000" cy="6858000" type="screen4x3"/>
   <p:notesSz cx="6858000" cy="9144000"/>
@@ -728,7 +730,7 @@
           <a:lstStyle/>
           <a:p>
             <a:r>
-              <a:t>Terraform defines a VPC with public and private subnets and a NAT gateway, an EKS cluster with a managed node group, and a GitHub OIDC role, so no access keys are stored. Terraform plan on a real AWS account shows sixty-four resources to add. My account's organisation policy blocks creating EC2 and EKS, so I verified the Kubernetes layer on a local cluster.</a:t>
+              <a:t>Terraform defines a VPC with public and private subnets and a NAT gateway, an EKS cluster with a managed node group and add-ons, and a GitHub OIDC role, so no access keys are stored anywhere. Terraform plan shows sixty-four resources to add.</a:t>
             </a:r>
           </a:p>
         </p:txBody>
@@ -798,7 +800,7 @@
           <a:lstStyle/>
           <a:p>
             <a:r>
-              <a:t>One Helm chart deploys everything: frontend and backend with two replicas each, a PostgreSQL StatefulSet, ClusterIP services, an autoscaler and disruption budgets, under the restricted pod security standard.</a:t>
+              <a:t>Then terraform apply built it for real in the Mumbai region. Here is the EKS cluster, active, and the VPC with its four subnets. After the demo, the teardown script removed everything with terraform destroy, so nothing keeps billing.</a:t>
             </a:r>
           </a:p>
         </p:txBody>
@@ -868,7 +870,7 @@
           <a:lstStyle/>
           <a:p>
             <a:r>
-              <a:t>An NGINX Ingress is the single entry point: slash goes to the frontend, and slash API and the docs go to the backend. Here's the app served through the Ingress hostname.</a:t>
+              <a:t>And here is MediSlot running on that EKS cluster. Helm deployed it, the pods are spread across both worker nodes, and the footer shows the production build with the exact commit SHA. The new AWS account wasn't allowed to create load balancers yet, so I reached the Ingress controller through a port-forward.</a:t>
             </a:r>
           </a:p>
         </p:txBody>
@@ -938,7 +940,7 @@
           <a:lstStyle/>
           <a:p>
             <a:r>
-              <a:t>Under a load test, CPU rose far past the sixty percent target, and the autoscaler scaled the backend from two pods to four, automatically.</a:t>
+              <a:t>One Helm chart deploys everything: frontend and backend with two replicas each, a PostgreSQL StatefulSet, ClusterIP services, an autoscaler and disruption budgets, under the restricted pod security standard.</a:t>
             </a:r>
           </a:p>
         </p:txBody>
@@ -1008,7 +1010,7 @@
           <a:lstStyle/>
           <a:p>
             <a:r>
-              <a:t>The backend exposes Prometheus metrics, a ServiceMonitor makes Prometheus scrape it, and a Grafana dashboard from the Helm chart shows request rate, latency, status codes and bookings. You can see the load test spike.</a:t>
+              <a:t>An NGINX Ingress is the single entry point: slash goes to the frontend, and slash API and the docs go to the backend. Here's the app served through the Ingress hostname.</a:t>
             </a:r>
           </a:p>
         </p:txBody>
@@ -1034,6 +1036,146 @@
 </file>
 
 <file path=ppt/notesSlides/notesSlide17.xml><?xml version="1.0" encoding="utf-8"?>
+<p:notes xmlns:a="http://schemas.openxmlformats.org/drawingml/2006/main" xmlns:p="http://schemas.openxmlformats.org/presentationml/2006/main" xmlns:r="http://schemas.openxmlformats.org/officeDocument/2006/relationships">
+  <p:cSld>
+    <p:spTree>
+      <p:nvGrpSpPr>
+        <p:cNvPr id="1" name=""/>
+        <p:cNvGrpSpPr/>
+        <p:nvPr/>
+      </p:nvGrpSpPr>
+      <p:grpSpPr>
+        <a:xfrm>
+          <a:off x="0" y="0"/>
+          <a:ext cx="0" cy="0"/>
+          <a:chOff x="0" y="0"/>
+          <a:chExt cx="0" cy="0"/>
+        </a:xfrm>
+      </p:grpSpPr>
+      <p:sp>
+        <p:nvSpPr>
+          <p:cNvPr id="2" name="Slide Image Placeholder 1"/>
+          <p:cNvSpPr>
+            <a:spLocks noGrp="1"/>
+          </p:cNvSpPr>
+          <p:nvPr>
+            <p:ph type="sldImg" idx="2"/>
+          </p:nvPr>
+        </p:nvSpPr>
+        <p:spPr/>
+      </p:sp>
+      <p:sp>
+        <p:nvSpPr>
+          <p:cNvPr id="3" name="Notes Placeholder 2"/>
+          <p:cNvSpPr>
+            <a:spLocks noGrp="1"/>
+          </p:cNvSpPr>
+          <p:nvPr>
+            <p:ph type="body" idx="3" sz="quarter"/>
+          </p:nvPr>
+        </p:nvSpPr>
+        <p:spPr/>
+        <p:txBody>
+          <a:bodyPr/>
+          <a:lstStyle/>
+          <a:p>
+            <a:r>
+              <a:t>Under a load test, CPU rose far past the sixty percent target, and the autoscaler scaled the backend from two pods to four, automatically.</a:t>
+            </a:r>
+          </a:p>
+        </p:txBody>
+      </p:sp>
+      <p:sp>
+        <p:nvSpPr>
+          <p:cNvPr id="4" name="Slide Number Placeholder 3"/>
+          <p:cNvSpPr>
+            <a:spLocks noGrp="1"/>
+          </p:cNvSpPr>
+          <p:nvPr>
+            <p:ph type="sldNum" idx="5" sz="quarter"/>
+          </p:nvPr>
+        </p:nvSpPr>
+        <p:spPr/>
+      </p:sp>
+    </p:spTree>
+  </p:cSld>
+  <p:clrMapOvr>
+    <a:masterClrMapping/>
+  </p:clrMapOvr>
+</p:notes>
+</file>
+
+<file path=ppt/notesSlides/notesSlide18.xml><?xml version="1.0" encoding="utf-8"?>
+<p:notes xmlns:a="http://schemas.openxmlformats.org/drawingml/2006/main" xmlns:p="http://schemas.openxmlformats.org/presentationml/2006/main" xmlns:r="http://schemas.openxmlformats.org/officeDocument/2006/relationships">
+  <p:cSld>
+    <p:spTree>
+      <p:nvGrpSpPr>
+        <p:cNvPr id="1" name=""/>
+        <p:cNvGrpSpPr/>
+        <p:nvPr/>
+      </p:nvGrpSpPr>
+      <p:grpSpPr>
+        <a:xfrm>
+          <a:off x="0" y="0"/>
+          <a:ext cx="0" cy="0"/>
+          <a:chOff x="0" y="0"/>
+          <a:chExt cx="0" cy="0"/>
+        </a:xfrm>
+      </p:grpSpPr>
+      <p:sp>
+        <p:nvSpPr>
+          <p:cNvPr id="2" name="Slide Image Placeholder 1"/>
+          <p:cNvSpPr>
+            <a:spLocks noGrp="1"/>
+          </p:cNvSpPr>
+          <p:nvPr>
+            <p:ph type="sldImg" idx="2"/>
+          </p:nvPr>
+        </p:nvSpPr>
+        <p:spPr/>
+      </p:sp>
+      <p:sp>
+        <p:nvSpPr>
+          <p:cNvPr id="3" name="Notes Placeholder 2"/>
+          <p:cNvSpPr>
+            <a:spLocks noGrp="1"/>
+          </p:cNvSpPr>
+          <p:nvPr>
+            <p:ph type="body" idx="3" sz="quarter"/>
+          </p:nvPr>
+        </p:nvSpPr>
+        <p:spPr/>
+        <p:txBody>
+          <a:bodyPr/>
+          <a:lstStyle/>
+          <a:p>
+            <a:r>
+              <a:t>The backend exposes Prometheus metrics, a ServiceMonitor makes Prometheus scrape it, and a Grafana dashboard from the Helm chart shows request rate, latency, status codes and bookings. You can see the load test spike.</a:t>
+            </a:r>
+          </a:p>
+        </p:txBody>
+      </p:sp>
+      <p:sp>
+        <p:nvSpPr>
+          <p:cNvPr id="4" name="Slide Number Placeholder 3"/>
+          <p:cNvSpPr>
+            <a:spLocks noGrp="1"/>
+          </p:cNvSpPr>
+          <p:nvPr>
+            <p:ph type="sldNum" idx="5" sz="quarter"/>
+          </p:nvPr>
+        </p:nvSpPr>
+        <p:spPr/>
+      </p:sp>
+    </p:spTree>
+  </p:cSld>
+  <p:clrMapOvr>
+    <a:masterClrMapping/>
+  </p:clrMapOvr>
+</p:notes>
+</file>
+
+<file path=ppt/notesSlides/notesSlide19.xml><?xml version="1.0" encoding="utf-8"?>
 <p:notes xmlns:a="http://schemas.openxmlformats.org/drawingml/2006/main" xmlns:p="http://schemas.openxmlformats.org/presentationml/2006/main" xmlns:r="http://schemas.openxmlformats.org/officeDocument/2006/relationships">
   <p:cSld>
     <p:spTree>
@@ -4983,6 +5125,90 @@
       <p:pic>
         <p:nvPicPr>
           <p:cNvPr id="2" name="Picture 1" descr="s16.png"/>
+          <p:cNvPicPr>
+            <a:picLocks noChangeAspect="1"/>
+          </p:cNvPicPr>
+          <p:nvPr/>
+        </p:nvPicPr>
+        <p:blipFill>
+          <a:blip r:embed="rId2"/>
+          <a:stretch>
+            <a:fillRect/>
+          </a:stretch>
+        </p:blipFill>
+        <p:spPr>
+          <a:xfrm>
+            <a:off x="0" y="0"/>
+            <a:ext cx="12192000" cy="6858000"/>
+          </a:xfrm>
+          <a:prstGeom prst="rect">
+            <a:avLst/>
+          </a:prstGeom>
+        </p:spPr>
+      </p:pic>
+    </p:spTree>
+  </p:cSld>
+  <p:clrMapOvr>
+    <a:masterClrMapping/>
+  </p:clrMapOvr>
+</p:sld>
+</file>
+
+<file path=ppt/slides/slide18.xml><?xml version="1.0" encoding="utf-8"?>
+<p:sld xmlns:a="http://schemas.openxmlformats.org/drawingml/2006/main" xmlns:p="http://schemas.openxmlformats.org/presentationml/2006/main" xmlns:r="http://schemas.openxmlformats.org/officeDocument/2006/relationships">
+  <p:cSld>
+    <p:spTree>
+      <p:nvGrpSpPr>
+        <p:cNvPr id="1" name=""/>
+        <p:cNvGrpSpPr/>
+        <p:nvPr/>
+      </p:nvGrpSpPr>
+      <p:grpSpPr/>
+      <p:pic>
+        <p:nvPicPr>
+          <p:cNvPr id="2" name="Picture 1" descr="s17.png"/>
+          <p:cNvPicPr>
+            <a:picLocks noChangeAspect="1"/>
+          </p:cNvPicPr>
+          <p:nvPr/>
+        </p:nvPicPr>
+        <p:blipFill>
+          <a:blip r:embed="rId2"/>
+          <a:stretch>
+            <a:fillRect/>
+          </a:stretch>
+        </p:blipFill>
+        <p:spPr>
+          <a:xfrm>
+            <a:off x="0" y="0"/>
+            <a:ext cx="12192000" cy="6858000"/>
+          </a:xfrm>
+          <a:prstGeom prst="rect">
+            <a:avLst/>
+          </a:prstGeom>
+        </p:spPr>
+      </p:pic>
+    </p:spTree>
+  </p:cSld>
+  <p:clrMapOvr>
+    <a:masterClrMapping/>
+  </p:clrMapOvr>
+</p:sld>
+</file>
+
+<file path=ppt/slides/slide19.xml><?xml version="1.0" encoding="utf-8"?>
+<p:sld xmlns:a="http://schemas.openxmlformats.org/drawingml/2006/main" xmlns:p="http://schemas.openxmlformats.org/presentationml/2006/main" xmlns:r="http://schemas.openxmlformats.org/officeDocument/2006/relationships">
+  <p:cSld>
+    <p:spTree>
+      <p:nvGrpSpPr>
+        <p:cNvPr id="1" name=""/>
+        <p:cNvGrpSpPr/>
+        <p:nvPr/>
+      </p:nvGrpSpPr>
+      <p:grpSpPr/>
+      <p:pic>
+        <p:nvPicPr>
+          <p:cNvPr id="2" name="Picture 1" descr="s18.png"/>
           <p:cNvPicPr>
             <a:picLocks noChangeAspect="1"/>
           </p:cNvPicPr>

</xml_diff>